<commit_message>
Deck v8: calculation-sheet links removed (the audience cannot open them); appendix rebuilt
Co-Authored-By: Claude Opus 5.5 <noreply@anthropic.com>
Claude-Session: https://claude.ai/code/session_012vxDhJBdXDDzxaEvKJXH5D
</commit_message>
<xml_diff>
--- a/docs/presentation/deck_v8/RoomCleaner_Buntinx_Oct27_v8_appendix.pptx
+++ b/docs/presentation/deck_v8/RoomCleaner_Buntinx_Oct27_v8_appendix.pptx
@@ -116,7 +116,7 @@
   <p:extLst>
     <p:ext uri="{521415D9-36F7-43E2-AB2F-B90AF26B5E84}">
       <p14:sectionLst xmlns:p14="http://schemas.microsoft.com/office/powerpoint/2010/main">
-        <p14:section name="Appendix" id="{5bca9940-d799-4bee-a7a5-b106b5c00d1a}">
+        <p14:section name="Appendix" id="{c04363ce-4685-7942-4c8f-5c43b7b7e128}">
           <p14:sldIdLst>
             <p14:sldId id="256"/>
             <p14:sldId id="257"/>
@@ -2179,52 +2179,6 @@
       </p:sp>
       <p:sp>
         <p:nvSpPr>
-          <p:cNvPr id="8" name="sheet link"/>
-          <p:cNvSpPr txBox="1"/>
-          <p:nvPr/>
-        </p:nvSpPr>
-        <p:spPr>
-          <a:xfrm>
-            <a:off x="7360920" y="4206240"/>
-            <a:ext cx="4297680" cy="365760"/>
-          </a:xfrm>
-          <a:prstGeom prst="rect">
-            <a:avLst/>
-          </a:prstGeom>
-          <a:noFill/>
-          <a:ln/>
-        </p:spPr>
-        <p:txBody>
-          <a:bodyPr wrap="square" lIns="0" tIns="0" rIns="0" bIns="0" rtlCol="0" anchor="ctr"/>
-          <a:lstStyle/>
-          <a:p>
-            <a:pPr indent="0" marL="0">
-              <a:buNone/>
-            </a:pPr>
-            <a:r>
-              <a:rPr lang="en-US" sz="1500" u="sng" dirty="0">
-                <a:solidFill>
-                  <a:srgbClr val="1F3A5F"/>
-                </a:solidFill>
-                <a:latin typeface="Arial" pitchFamily="34" charset="0"/>
-                <a:ea typeface="Arial" pitchFamily="34" charset="-122"/>
-                <a:cs typeface="Arial" pitchFamily="34" charset="-120"/>
-                <a:hlinkClick r:id="rId2" invalidUrl="" action="" tgtFrame="" tooltip="Open the calculation sheet" history="1" highlightClick="0" endSnd="0">
-                  <a:extLst>
-                    <a:ext uri="{A12FA001-AC4F-418D-AE19-62706E023703}">
-                      <ahyp:hlinkClr xmlns:ahyp="http://schemas.microsoft.com/office/drawing/2018/hyperlinkcolor" val="tx"/>
-                    </a:ext>
-                  </a:extLst>
-                </a:hlinkClick>
-              </a:rPr>
-              <a:t>RoomCleaner engineering calculations (Google Sheets)</a:t>
-            </a:r>
-            <a:endParaRPr lang="en-US" sz="1500" dirty="0"/>
-          </a:p>
-        </p:txBody>
-      </p:sp>
-      <p:sp>
-        <p:nvSpPr>
           <p:cNvPr id="25" name="Slide Number Placeholder 0"/>
           <p:cNvSpPr>
             <a:spLocks noGrp="1"/>

</xml_diff>